<commit_message>
Modified Markdown export method
</commit_message>
<xml_diff>
--- a/doc/基本設計.pptx
+++ b/doc/基本設計.pptx
@@ -109,6 +109,11 @@
       </a:defRPr>
     </a:lvl9pPr>
   </p:defaultTextStyle>
+  <p:extLst>
+    <p:ext uri="{EFAFB233-063F-42B5-8137-9DF3F51BA10A}">
+      <p15:sldGuideLst xmlns:p15="http://schemas.microsoft.com/office/powerpoint/2012/main"/>
+    </p:ext>
+  </p:extLst>
 </p:presentation>
 </file>
 
@@ -3477,8 +3482,12 @@
           <a:lstStyle/>
           <a:p>
             <a:r>
+              <a:rPr lang="en-US" altLang="ja-JP" smtClean="0"/>
+              <a:t>2026/07/05 </a:t>
+            </a:r>
+            <a:r>
               <a:rPr lang="en-US" altLang="ja-JP" dirty="0"/>
-              <a:t>20260705 HidetoshiNITTA931</a:t>
+              <a:t>HidetoshiNITTA931</a:t>
             </a:r>
             <a:endParaRPr kumimoji="1" lang="ja-JP" altLang="en-US" dirty="0"/>
           </a:p>
@@ -8668,7 +8677,7 @@
         </p:spPr>
         <p:txBody>
           <a:bodyPr>
-            <a:normAutofit lnSpcReduction="10000"/>
+            <a:normAutofit fontScale="92500" lnSpcReduction="10000"/>
           </a:bodyPr>
           <a:lstStyle/>
           <a:p>
@@ -8740,6 +8749,10 @@
           <a:p>
             <a:pPr lvl="1"/>
             <a:endParaRPr lang="en-US" altLang="ja-JP" dirty="0"/>
+          </a:p>
+          <a:p>
+            <a:pPr lvl="1"/>
+            <a:endParaRPr lang="en-US" altLang="ja-JP" dirty="0" smtClean="0"/>
           </a:p>
           <a:p>
             <a:pPr lvl="1"/>
@@ -8783,14 +8796,14 @@
           <p:nvPr>
             <p:extLst>
               <p:ext uri="{D42A27DB-BD31-4B8C-83A1-F6EECF244321}">
-                <p14:modId xmlns:p14="http://schemas.microsoft.com/office/powerpoint/2010/main" val="1095490529"/>
+                <p14:modId xmlns:p14="http://schemas.microsoft.com/office/powerpoint/2010/main" val="1496377620"/>
               </p:ext>
             </p:extLst>
           </p:nvPr>
         </p:nvGraphicFramePr>
         <p:xfrm>
-          <a:off x="1082431" y="2316357"/>
-          <a:ext cx="8128000" cy="3017520"/>
+          <a:off x="1513254" y="1964665"/>
+          <a:ext cx="9459546" cy="3268980"/>
         </p:xfrm>
         <a:graphic>
           <a:graphicData uri="http://schemas.openxmlformats.org/drawingml/2006/table">
@@ -8799,12 +8812,12 @@
                 <a:tableStyleId>{5C22544A-7EE6-4342-B048-85BDC9FD1C3A}</a:tableStyleId>
               </a:tblPr>
               <a:tblGrid>
-                <a:gridCol w="1616807"/>
-                <a:gridCol w="545124"/>
-                <a:gridCol w="1019907"/>
-                <a:gridCol w="4946162"/>
+                <a:gridCol w="1881676"/>
+                <a:gridCol w="634427"/>
+                <a:gridCol w="1186990"/>
+                <a:gridCol w="5756453"/>
               </a:tblGrid>
-              <a:tr h="139015">
+              <a:tr h="199212">
                 <a:tc>
                   <a:txBody>
                     <a:bodyPr/>
@@ -8863,7 +8876,7 @@
                   <a:tcPr/>
                 </a:tc>
               </a:tr>
-              <a:tr h="139015">
+              <a:tr h="199212">
                 <a:tc>
                   <a:txBody>
                     <a:bodyPr/>
@@ -8918,7 +8931,7 @@
                   <a:tcPr/>
                 </a:tc>
               </a:tr>
-              <a:tr h="139015">
+              <a:tr h="199212">
                 <a:tc>
                   <a:txBody>
                     <a:bodyPr/>
@@ -8973,7 +8986,7 @@
                   <a:tcPr/>
                 </a:tc>
               </a:tr>
-              <a:tr h="130568">
+              <a:tr h="199212">
                 <a:tc>
                   <a:txBody>
                     <a:bodyPr/>
@@ -9028,7 +9041,7 @@
                   <a:tcPr/>
                 </a:tc>
               </a:tr>
-              <a:tr h="130568">
+              <a:tr h="199212">
                 <a:tc>
                   <a:txBody>
                     <a:bodyPr/>
@@ -9053,11 +9066,7 @@
                       </a:pPr>
                       <a:r>
                         <a:rPr kumimoji="1" lang="ja-JP" altLang="en-US" sz="1050" dirty="0" smtClean="0"/>
-                        <a:t>出力する</a:t>
-                      </a:r>
-                      <a:r>
-                        <a:rPr kumimoji="1" lang="ja-JP" altLang="en-US" sz="1050" dirty="0" smtClean="0"/>
-                        <a:t>工事名（</a:t>
+                        <a:t>出力する工事名（</a:t>
                       </a:r>
                       <a:r>
                         <a:rPr kumimoji="1" lang="en-US" altLang="ja-JP" sz="1050" dirty="0" smtClean="0"/>
@@ -9111,7 +9120,7 @@
                   <a:tcPr/>
                 </a:tc>
               </a:tr>
-              <a:tr h="130568">
+              <a:tr h="199212">
                 <a:tc>
                   <a:txBody>
                     <a:bodyPr/>
@@ -9166,7 +9175,7 @@
                   <a:tcPr/>
                 </a:tc>
               </a:tr>
-              <a:tr h="130568">
+              <a:tr h="199212">
                 <a:tc>
                   <a:txBody>
                     <a:bodyPr/>
@@ -9221,7 +9230,7 @@
                   <a:tcPr/>
                 </a:tc>
               </a:tr>
-              <a:tr h="130568">
+              <a:tr h="199212">
                 <a:tc>
                   <a:txBody>
                     <a:bodyPr/>
@@ -9276,7 +9285,7 @@
                   <a:tcPr/>
                 </a:tc>
               </a:tr>
-              <a:tr h="130568">
+              <a:tr h="199212">
                 <a:tc>
                   <a:txBody>
                     <a:bodyPr/>
@@ -9335,7 +9344,62 @@
                   <a:tcPr/>
                 </a:tc>
               </a:tr>
-              <a:tr h="130568">
+              <a:tr h="199212">
+                <a:tc>
+                  <a:txBody>
+                    <a:bodyPr/>
+                    <a:lstStyle/>
+                    <a:p>
+                      <a:r>
+                        <a:rPr kumimoji="1" lang="ja-JP" altLang="en-US" sz="1050" dirty="0" smtClean="0"/>
+                        <a:t>申し送り事項を出力しない</a:t>
+                      </a:r>
+                      <a:endParaRPr kumimoji="1" lang="ja-JP" altLang="en-US" sz="1050" dirty="0"/>
+                    </a:p>
+                  </a:txBody>
+                  <a:tcPr/>
+                </a:tc>
+                <a:tc>
+                  <a:txBody>
+                    <a:bodyPr/>
+                    <a:lstStyle/>
+                    <a:p>
+                      <a:pPr algn="ctr"/>
+                      <a:r>
+                        <a:rPr kumimoji="1" lang="en-US" altLang="ja-JP" sz="1050" dirty="0" smtClean="0"/>
+                        <a:t>×</a:t>
+                      </a:r>
+                      <a:endParaRPr kumimoji="1" lang="ja-JP" altLang="en-US" sz="1050" dirty="0"/>
+                    </a:p>
+                  </a:txBody>
+                  <a:tcPr/>
+                </a:tc>
+                <a:tc>
+                  <a:txBody>
+                    <a:bodyPr/>
+                    <a:lstStyle/>
+                    <a:p>
+                      <a:r>
+                        <a:rPr kumimoji="1" lang="en-US" altLang="ja-JP" sz="1050" dirty="0" smtClean="0"/>
+                        <a:t>CLI</a:t>
+                      </a:r>
+                      <a:endParaRPr kumimoji="1" lang="ja-JP" altLang="en-US" sz="1050" dirty="0"/>
+                    </a:p>
+                  </a:txBody>
+                  <a:tcPr/>
+                </a:tc>
+                <a:tc>
+                  <a:txBody>
+                    <a:bodyPr/>
+                    <a:lstStyle/>
+                    <a:p>
+                      <a:endParaRPr kumimoji="1" lang="ja-JP" altLang="en-US" sz="1050" dirty="0"/>
+                    </a:p>
+                  </a:txBody>
+                  <a:tcPr/>
+                </a:tc>
+              </a:tr>
+              <a:tr h="199212">
                 <a:tc>
                   <a:txBody>
                     <a:bodyPr/>
@@ -9390,7 +9454,7 @@
                   <a:tcPr/>
                 </a:tc>
               </a:tr>
-              <a:tr h="130568">
+              <a:tr h="199212">
                 <a:tc>
                   <a:txBody>
                     <a:bodyPr/>
@@ -9461,7 +9525,7 @@
                   <a:tcPr/>
                 </a:tc>
               </a:tr>
-              <a:tr h="130568">
+              <a:tr h="199212">
                 <a:tc>
                   <a:txBody>
                     <a:bodyPr/>

</xml_diff>